<commit_message>
Name the four bonus recipients and show the total pot
The scheme pays Emily, Stuart, Cassie and Megan. Each rung of the ladder
now carries the total cost alongside the per-person figure, which comes
to 10% of the excess above 9m at every step and 100,000 at 10m.

Co-Authored-By: Claude Opus 5 <noreply@anthropic.com>
Claude-Session: https://claude.ai/code/session_01Bu1rr52xwzmQs6BFkMG9oT
</commit_message>
<xml_diff>
--- a/reports/ytd-road-to-9m.pptx
+++ b/reports/ytd-road-to-9m.pptx
@@ -2949,7 +2949,7 @@
           <a:p>
             <a:r>
               <a:rPr lang="en-US" dirty="0"/>
-              <a:t>Now the part worth staying for. &lt;break time="0.8s"/&gt; Nine million is the goal. &lt;break time="0.5s"/&gt; Everything above it is shared. &lt;break time="0.8s"/&gt; For every two hundred thousand pounds over nine million, &lt;break time="0.5s"/&gt; five thousand pounds each. &lt;break time="0.9s"/&gt; Nine point two million is five thousand. &lt;break time="0.5s"/&gt; Nine point six is fifteen. &lt;break time="0.6s"/&gt; And ten million &lt;break time="0.4s"/&gt; is twenty five thousand pounds each. &lt;break time="1s"/&gt;</a:t>
+              <a:t>Now the part worth staying for. &lt;break time="0.8s"/&gt; Nine million is the goal. &lt;break time="0.5s"/&gt; Everything above it is shared between the four of you. &lt;break time="0.6s"/&gt; Emily, &lt;break time="0.25s"/&gt; Stuart, &lt;break time="0.25s"/&gt; Cassie &lt;break time="0.25s"/&gt; and Megan. &lt;break time="0.9s"/&gt; For every two hundred thousand over nine million, &lt;break time="0.5s"/&gt; five thousand pounds each. &lt;break time="0.8s"/&gt; Nine point six million is fifteen thousand. &lt;break time="0.6s"/&gt; And ten million &lt;break time="0.4s"/&gt; is twenty five thousand pounds each. &lt;break time="1s"/&gt;</a:t>
             </a:r>
             <a:endParaRPr lang="en-US" dirty="0"/>
           </a:p>
@@ -7244,7 +7244,7 @@
                 <a:ea typeface="Calibri" pitchFamily="34" charset="-122"/>
                 <a:cs typeface="Calibri" pitchFamily="34" charset="-120"/>
               </a:rPr>
-              <a:t>The nine million is the goal. Everything above it is shared — and it steps up every two hundred thousand.</a:t>
+              <a:t>For Emily, Stuart, Cassie and Megan. Nine million is the goal — everything above it is shared, and it steps up every two hundred thousand.</a:t>
             </a:r>
             <a:endParaRPr lang="en-US" sz="1500" dirty="0"/>
           </a:p>
@@ -7258,8 +7258,8 @@
         </p:nvSpPr>
         <p:spPr>
           <a:xfrm>
-            <a:off x="548640" y="2286000"/>
-            <a:ext cx="2103120" cy="2286000"/>
+            <a:off x="548640" y="2331720"/>
+            <a:ext cx="2103120" cy="2240280"/>
           </a:xfrm>
           <a:prstGeom prst="rect">
             <a:avLst/>
@@ -7283,8 +7283,8 @@
         </p:nvSpPr>
         <p:spPr>
           <a:xfrm>
-            <a:off x="731520" y="2487168"/>
-            <a:ext cx="1737360" cy="365760"/>
+            <a:off x="685800" y="2505456"/>
+            <a:ext cx="1828800" cy="310896"/>
           </a:xfrm>
           <a:prstGeom prst="rect">
             <a:avLst/>
@@ -7322,8 +7322,8 @@
         </p:nvSpPr>
         <p:spPr>
           <a:xfrm>
-            <a:off x="685800" y="3017520"/>
-            <a:ext cx="1828800" cy="685800"/>
+            <a:off x="658368" y="2907792"/>
+            <a:ext cx="1883664" cy="658368"/>
           </a:xfrm>
           <a:prstGeom prst="rect">
             <a:avLst/>
@@ -7339,7 +7339,7 @@
               <a:buNone/>
             </a:pPr>
             <a:r>
-              <a:rPr lang="en-US" sz="2800" b="1" dirty="0">
+              <a:rPr lang="en-US" sz="2700" b="1" dirty="0">
                 <a:solidFill>
                   <a:srgbClr val="E7EEEC"/>
                 </a:solidFill>
@@ -7349,7 +7349,7 @@
               </a:rPr>
               <a:t>£5,000</a:t>
             </a:r>
-            <a:endParaRPr lang="en-US" sz="2800" dirty="0"/>
+            <a:endParaRPr lang="en-US" sz="2700" dirty="0"/>
           </a:p>
         </p:txBody>
       </p:sp>
@@ -7361,8 +7361,8 @@
         </p:nvSpPr>
         <p:spPr>
           <a:xfrm>
-            <a:off x="731520" y="3794760"/>
-            <a:ext cx="1737360" cy="274320"/>
+            <a:off x="685800" y="3584448"/>
+            <a:ext cx="1828800" cy="256032"/>
           </a:xfrm>
           <a:prstGeom prst="rect">
             <a:avLst/>
@@ -7394,14 +7394,53 @@
       </p:sp>
       <p:sp>
         <p:nvSpPr>
-          <p:cNvPr id="9" name="Shape 7"/>
+          <p:cNvPr id="9" name="Text 7"/>
+          <p:cNvSpPr txBox="1"/>
+          <p:nvPr/>
+        </p:nvSpPr>
+        <p:spPr>
+          <a:xfrm>
+            <a:off x="658368" y="3968496"/>
+            <a:ext cx="1883664" cy="274320"/>
+          </a:xfrm>
+          <a:prstGeom prst="rect">
+            <a:avLst/>
+          </a:prstGeom>
+          <a:noFill/>
+          <a:ln/>
+        </p:spPr>
+        <p:txBody>
+          <a:bodyPr wrap="square" lIns="0" tIns="0" rIns="0" bIns="0" rtlCol="0" anchor="ctr"/>
+          <a:lstStyle/>
+          <a:p>
+            <a:pPr algn="ctr" indent="0" marL="0">
+              <a:buNone/>
+            </a:pPr>
+            <a:r>
+              <a:rPr lang="en-US" sz="1100" b="1" dirty="0">
+                <a:solidFill>
+                  <a:srgbClr val="0E8A94"/>
+                </a:solidFill>
+                <a:latin typeface="Courier New" pitchFamily="34" charset="0"/>
+                <a:ea typeface="Courier New" pitchFamily="34" charset="-122"/>
+                <a:cs typeface="Courier New" pitchFamily="34" charset="-120"/>
+              </a:rPr>
+              <a:t>£20,000 in total</a:t>
+            </a:r>
+            <a:endParaRPr lang="en-US" sz="1100" dirty="0"/>
+          </a:p>
+        </p:txBody>
+      </p:sp>
+      <p:sp>
+        <p:nvSpPr>
+          <p:cNvPr id="10" name="Shape 8"/>
           <p:cNvSpPr/>
           <p:nvPr/>
         </p:nvSpPr>
         <p:spPr>
           <a:xfrm>
-            <a:off x="2807208" y="2286000"/>
-            <a:ext cx="2103120" cy="2286000"/>
+            <a:off x="2807208" y="2331720"/>
+            <a:ext cx="2103120" cy="2240280"/>
           </a:xfrm>
           <a:prstGeom prst="rect">
             <a:avLst/>
@@ -7419,14 +7458,14 @@
       </p:sp>
       <p:sp>
         <p:nvSpPr>
-          <p:cNvPr id="10" name="Text 8"/>
-          <p:cNvSpPr txBox="1"/>
-          <p:nvPr/>
-        </p:nvSpPr>
-        <p:spPr>
-          <a:xfrm>
-            <a:off x="2990088" y="2487168"/>
-            <a:ext cx="1737360" cy="365760"/>
+          <p:cNvPr id="11" name="Text 9"/>
+          <p:cNvSpPr txBox="1"/>
+          <p:nvPr/>
+        </p:nvSpPr>
+        <p:spPr>
+          <a:xfrm>
+            <a:off x="2944368" y="2505456"/>
+            <a:ext cx="1828800" cy="310896"/>
           </a:xfrm>
           <a:prstGeom prst="rect">
             <a:avLst/>
@@ -7458,14 +7497,14 @@
       </p:sp>
       <p:sp>
         <p:nvSpPr>
-          <p:cNvPr id="11" name="Text 9"/>
-          <p:cNvSpPr txBox="1"/>
-          <p:nvPr/>
-        </p:nvSpPr>
-        <p:spPr>
-          <a:xfrm>
-            <a:off x="2944368" y="3017520"/>
-            <a:ext cx="1828800" cy="685800"/>
+          <p:cNvPr id="12" name="Text 10"/>
+          <p:cNvSpPr txBox="1"/>
+          <p:nvPr/>
+        </p:nvSpPr>
+        <p:spPr>
+          <a:xfrm>
+            <a:off x="2916936" y="2907792"/>
+            <a:ext cx="1883664" cy="658368"/>
           </a:xfrm>
           <a:prstGeom prst="rect">
             <a:avLst/>
@@ -7481,7 +7520,7 @@
               <a:buNone/>
             </a:pPr>
             <a:r>
-              <a:rPr lang="en-US" sz="2800" b="1" dirty="0">
+              <a:rPr lang="en-US" sz="2700" b="1" dirty="0">
                 <a:solidFill>
                   <a:srgbClr val="E7EEEC"/>
                 </a:solidFill>
@@ -7491,20 +7530,20 @@
               </a:rPr>
               <a:t>£10,000</a:t>
             </a:r>
-            <a:endParaRPr lang="en-US" sz="2800" dirty="0"/>
-          </a:p>
-        </p:txBody>
-      </p:sp>
-      <p:sp>
-        <p:nvSpPr>
-          <p:cNvPr id="12" name="Text 10"/>
-          <p:cNvSpPr txBox="1"/>
-          <p:nvPr/>
-        </p:nvSpPr>
-        <p:spPr>
-          <a:xfrm>
-            <a:off x="2990088" y="3794760"/>
-            <a:ext cx="1737360" cy="274320"/>
+            <a:endParaRPr lang="en-US" sz="2700" dirty="0"/>
+          </a:p>
+        </p:txBody>
+      </p:sp>
+      <p:sp>
+        <p:nvSpPr>
+          <p:cNvPr id="13" name="Text 11"/>
+          <p:cNvSpPr txBox="1"/>
+          <p:nvPr/>
+        </p:nvSpPr>
+        <p:spPr>
+          <a:xfrm>
+            <a:off x="2944368" y="3584448"/>
+            <a:ext cx="1828800" cy="256032"/>
           </a:xfrm>
           <a:prstGeom prst="rect">
             <a:avLst/>
@@ -7536,14 +7575,53 @@
       </p:sp>
       <p:sp>
         <p:nvSpPr>
-          <p:cNvPr id="13" name="Shape 11"/>
+          <p:cNvPr id="14" name="Text 12"/>
+          <p:cNvSpPr txBox="1"/>
+          <p:nvPr/>
+        </p:nvSpPr>
+        <p:spPr>
+          <a:xfrm>
+            <a:off x="2916936" y="3968496"/>
+            <a:ext cx="1883664" cy="274320"/>
+          </a:xfrm>
+          <a:prstGeom prst="rect">
+            <a:avLst/>
+          </a:prstGeom>
+          <a:noFill/>
+          <a:ln/>
+        </p:spPr>
+        <p:txBody>
+          <a:bodyPr wrap="square" lIns="0" tIns="0" rIns="0" bIns="0" rtlCol="0" anchor="ctr"/>
+          <a:lstStyle/>
+          <a:p>
+            <a:pPr algn="ctr" indent="0" marL="0">
+              <a:buNone/>
+            </a:pPr>
+            <a:r>
+              <a:rPr lang="en-US" sz="1100" b="1" dirty="0">
+                <a:solidFill>
+                  <a:srgbClr val="0E8A94"/>
+                </a:solidFill>
+                <a:latin typeface="Courier New" pitchFamily="34" charset="0"/>
+                <a:ea typeface="Courier New" pitchFamily="34" charset="-122"/>
+                <a:cs typeface="Courier New" pitchFamily="34" charset="-120"/>
+              </a:rPr>
+              <a:t>£40,000 in total</a:t>
+            </a:r>
+            <a:endParaRPr lang="en-US" sz="1100" dirty="0"/>
+          </a:p>
+        </p:txBody>
+      </p:sp>
+      <p:sp>
+        <p:nvSpPr>
+          <p:cNvPr id="15" name="Shape 13"/>
           <p:cNvSpPr/>
           <p:nvPr/>
         </p:nvSpPr>
         <p:spPr>
           <a:xfrm>
-            <a:off x="5065776" y="2286000"/>
-            <a:ext cx="2103120" cy="2286000"/>
+            <a:off x="5065776" y="2331720"/>
+            <a:ext cx="2103120" cy="2240280"/>
           </a:xfrm>
           <a:prstGeom prst="rect">
             <a:avLst/>
@@ -7561,14 +7639,14 @@
       </p:sp>
       <p:sp>
         <p:nvSpPr>
-          <p:cNvPr id="14" name="Text 12"/>
-          <p:cNvSpPr txBox="1"/>
-          <p:nvPr/>
-        </p:nvSpPr>
-        <p:spPr>
-          <a:xfrm>
-            <a:off x="5248656" y="2487168"/>
-            <a:ext cx="1737360" cy="365760"/>
+          <p:cNvPr id="16" name="Text 14"/>
+          <p:cNvSpPr txBox="1"/>
+          <p:nvPr/>
+        </p:nvSpPr>
+        <p:spPr>
+          <a:xfrm>
+            <a:off x="5202936" y="2505456"/>
+            <a:ext cx="1828800" cy="310896"/>
           </a:xfrm>
           <a:prstGeom prst="rect">
             <a:avLst/>
@@ -7600,14 +7678,14 @@
       </p:sp>
       <p:sp>
         <p:nvSpPr>
-          <p:cNvPr id="15" name="Text 13"/>
-          <p:cNvSpPr txBox="1"/>
-          <p:nvPr/>
-        </p:nvSpPr>
-        <p:spPr>
-          <a:xfrm>
-            <a:off x="5202936" y="3017520"/>
-            <a:ext cx="1828800" cy="685800"/>
+          <p:cNvPr id="17" name="Text 15"/>
+          <p:cNvSpPr txBox="1"/>
+          <p:nvPr/>
+        </p:nvSpPr>
+        <p:spPr>
+          <a:xfrm>
+            <a:off x="5175504" y="2907792"/>
+            <a:ext cx="1883664" cy="658368"/>
           </a:xfrm>
           <a:prstGeom prst="rect">
             <a:avLst/>
@@ -7623,7 +7701,7 @@
               <a:buNone/>
             </a:pPr>
             <a:r>
-              <a:rPr lang="en-US" sz="2800" b="1" dirty="0">
+              <a:rPr lang="en-US" sz="2700" b="1" dirty="0">
                 <a:solidFill>
                   <a:srgbClr val="E7EEEC"/>
                 </a:solidFill>
@@ -7633,20 +7711,20 @@
               </a:rPr>
               <a:t>£15,000</a:t>
             </a:r>
-            <a:endParaRPr lang="en-US" sz="2800" dirty="0"/>
-          </a:p>
-        </p:txBody>
-      </p:sp>
-      <p:sp>
-        <p:nvSpPr>
-          <p:cNvPr id="16" name="Text 14"/>
-          <p:cNvSpPr txBox="1"/>
-          <p:nvPr/>
-        </p:nvSpPr>
-        <p:spPr>
-          <a:xfrm>
-            <a:off x="5248656" y="3794760"/>
-            <a:ext cx="1737360" cy="274320"/>
+            <a:endParaRPr lang="en-US" sz="2700" dirty="0"/>
+          </a:p>
+        </p:txBody>
+      </p:sp>
+      <p:sp>
+        <p:nvSpPr>
+          <p:cNvPr id="18" name="Text 16"/>
+          <p:cNvSpPr txBox="1"/>
+          <p:nvPr/>
+        </p:nvSpPr>
+        <p:spPr>
+          <a:xfrm>
+            <a:off x="5202936" y="3584448"/>
+            <a:ext cx="1828800" cy="256032"/>
           </a:xfrm>
           <a:prstGeom prst="rect">
             <a:avLst/>
@@ -7678,14 +7756,53 @@
       </p:sp>
       <p:sp>
         <p:nvSpPr>
-          <p:cNvPr id="17" name="Shape 15"/>
+          <p:cNvPr id="19" name="Text 17"/>
+          <p:cNvSpPr txBox="1"/>
+          <p:nvPr/>
+        </p:nvSpPr>
+        <p:spPr>
+          <a:xfrm>
+            <a:off x="5175504" y="3968496"/>
+            <a:ext cx="1883664" cy="274320"/>
+          </a:xfrm>
+          <a:prstGeom prst="rect">
+            <a:avLst/>
+          </a:prstGeom>
+          <a:noFill/>
+          <a:ln/>
+        </p:spPr>
+        <p:txBody>
+          <a:bodyPr wrap="square" lIns="0" tIns="0" rIns="0" bIns="0" rtlCol="0" anchor="ctr"/>
+          <a:lstStyle/>
+          <a:p>
+            <a:pPr algn="ctr" indent="0" marL="0">
+              <a:buNone/>
+            </a:pPr>
+            <a:r>
+              <a:rPr lang="en-US" sz="1100" b="1" dirty="0">
+                <a:solidFill>
+                  <a:srgbClr val="0E8A94"/>
+                </a:solidFill>
+                <a:latin typeface="Courier New" pitchFamily="34" charset="0"/>
+                <a:ea typeface="Courier New" pitchFamily="34" charset="-122"/>
+                <a:cs typeface="Courier New" pitchFamily="34" charset="-120"/>
+              </a:rPr>
+              <a:t>£60,000 in total</a:t>
+            </a:r>
+            <a:endParaRPr lang="en-US" sz="1100" dirty="0"/>
+          </a:p>
+        </p:txBody>
+      </p:sp>
+      <p:sp>
+        <p:nvSpPr>
+          <p:cNvPr id="20" name="Shape 18"/>
           <p:cNvSpPr/>
           <p:nvPr/>
         </p:nvSpPr>
         <p:spPr>
           <a:xfrm>
-            <a:off x="7324344" y="2286000"/>
-            <a:ext cx="2103120" cy="2286000"/>
+            <a:off x="7324344" y="2331720"/>
+            <a:ext cx="2103120" cy="2240280"/>
           </a:xfrm>
           <a:prstGeom prst="rect">
             <a:avLst/>
@@ -7703,14 +7820,14 @@
       </p:sp>
       <p:sp>
         <p:nvSpPr>
-          <p:cNvPr id="18" name="Text 16"/>
-          <p:cNvSpPr txBox="1"/>
-          <p:nvPr/>
-        </p:nvSpPr>
-        <p:spPr>
-          <a:xfrm>
-            <a:off x="7507224" y="2487168"/>
-            <a:ext cx="1737360" cy="365760"/>
+          <p:cNvPr id="21" name="Text 19"/>
+          <p:cNvSpPr txBox="1"/>
+          <p:nvPr/>
+        </p:nvSpPr>
+        <p:spPr>
+          <a:xfrm>
+            <a:off x="7461504" y="2505456"/>
+            <a:ext cx="1828800" cy="310896"/>
           </a:xfrm>
           <a:prstGeom prst="rect">
             <a:avLst/>
@@ -7742,14 +7859,14 @@
       </p:sp>
       <p:sp>
         <p:nvSpPr>
-          <p:cNvPr id="19" name="Text 17"/>
-          <p:cNvSpPr txBox="1"/>
-          <p:nvPr/>
-        </p:nvSpPr>
-        <p:spPr>
-          <a:xfrm>
-            <a:off x="7461504" y="3017520"/>
-            <a:ext cx="1828800" cy="685800"/>
+          <p:cNvPr id="22" name="Text 20"/>
+          <p:cNvSpPr txBox="1"/>
+          <p:nvPr/>
+        </p:nvSpPr>
+        <p:spPr>
+          <a:xfrm>
+            <a:off x="7434072" y="2907792"/>
+            <a:ext cx="1883664" cy="658368"/>
           </a:xfrm>
           <a:prstGeom prst="rect">
             <a:avLst/>
@@ -7765,7 +7882,7 @@
               <a:buNone/>
             </a:pPr>
             <a:r>
-              <a:rPr lang="en-US" sz="2800" b="1" dirty="0">
+              <a:rPr lang="en-US" sz="2700" b="1" dirty="0">
                 <a:solidFill>
                   <a:srgbClr val="E7EEEC"/>
                 </a:solidFill>
@@ -7775,20 +7892,20 @@
               </a:rPr>
               <a:t>£20,000</a:t>
             </a:r>
-            <a:endParaRPr lang="en-US" sz="2800" dirty="0"/>
-          </a:p>
-        </p:txBody>
-      </p:sp>
-      <p:sp>
-        <p:nvSpPr>
-          <p:cNvPr id="20" name="Text 18"/>
-          <p:cNvSpPr txBox="1"/>
-          <p:nvPr/>
-        </p:nvSpPr>
-        <p:spPr>
-          <a:xfrm>
-            <a:off x="7507224" y="3794760"/>
-            <a:ext cx="1737360" cy="274320"/>
+            <a:endParaRPr lang="en-US" sz="2700" dirty="0"/>
+          </a:p>
+        </p:txBody>
+      </p:sp>
+      <p:sp>
+        <p:nvSpPr>
+          <p:cNvPr id="23" name="Text 21"/>
+          <p:cNvSpPr txBox="1"/>
+          <p:nvPr/>
+        </p:nvSpPr>
+        <p:spPr>
+          <a:xfrm>
+            <a:off x="7461504" y="3584448"/>
+            <a:ext cx="1828800" cy="256032"/>
           </a:xfrm>
           <a:prstGeom prst="rect">
             <a:avLst/>
@@ -7820,14 +7937,53 @@
       </p:sp>
       <p:sp>
         <p:nvSpPr>
-          <p:cNvPr id="21" name="Shape 19"/>
+          <p:cNvPr id="24" name="Text 22"/>
+          <p:cNvSpPr txBox="1"/>
+          <p:nvPr/>
+        </p:nvSpPr>
+        <p:spPr>
+          <a:xfrm>
+            <a:off x="7434072" y="3968496"/>
+            <a:ext cx="1883664" cy="274320"/>
+          </a:xfrm>
+          <a:prstGeom prst="rect">
+            <a:avLst/>
+          </a:prstGeom>
+          <a:noFill/>
+          <a:ln/>
+        </p:spPr>
+        <p:txBody>
+          <a:bodyPr wrap="square" lIns="0" tIns="0" rIns="0" bIns="0" rtlCol="0" anchor="ctr"/>
+          <a:lstStyle/>
+          <a:p>
+            <a:pPr algn="ctr" indent="0" marL="0">
+              <a:buNone/>
+            </a:pPr>
+            <a:r>
+              <a:rPr lang="en-US" sz="1100" b="1" dirty="0">
+                <a:solidFill>
+                  <a:srgbClr val="0E8A94"/>
+                </a:solidFill>
+                <a:latin typeface="Courier New" pitchFamily="34" charset="0"/>
+                <a:ea typeface="Courier New" pitchFamily="34" charset="-122"/>
+                <a:cs typeface="Courier New" pitchFamily="34" charset="-120"/>
+              </a:rPr>
+              <a:t>£80,000 in total</a:t>
+            </a:r>
+            <a:endParaRPr lang="en-US" sz="1100" dirty="0"/>
+          </a:p>
+        </p:txBody>
+      </p:sp>
+      <p:sp>
+        <p:nvSpPr>
+          <p:cNvPr id="25" name="Shape 23"/>
           <p:cNvSpPr/>
           <p:nvPr/>
         </p:nvSpPr>
         <p:spPr>
           <a:xfrm>
-            <a:off x="9582912" y="2286000"/>
-            <a:ext cx="2103120" cy="2286000"/>
+            <a:off x="9582912" y="2331720"/>
+            <a:ext cx="2103120" cy="2240280"/>
           </a:xfrm>
           <a:prstGeom prst="rect">
             <a:avLst/>
@@ -7845,14 +8001,14 @@
       </p:sp>
       <p:sp>
         <p:nvSpPr>
-          <p:cNvPr id="22" name="Text 20"/>
-          <p:cNvSpPr txBox="1"/>
-          <p:nvPr/>
-        </p:nvSpPr>
-        <p:spPr>
-          <a:xfrm>
-            <a:off x="9765792" y="2487168"/>
-            <a:ext cx="1737360" cy="365760"/>
+          <p:cNvPr id="26" name="Text 24"/>
+          <p:cNvSpPr txBox="1"/>
+          <p:nvPr/>
+        </p:nvSpPr>
+        <p:spPr>
+          <a:xfrm>
+            <a:off x="9720072" y="2505456"/>
+            <a:ext cx="1828800" cy="310896"/>
           </a:xfrm>
           <a:prstGeom prst="rect">
             <a:avLst/>
@@ -7884,14 +8040,14 @@
       </p:sp>
       <p:sp>
         <p:nvSpPr>
-          <p:cNvPr id="23" name="Text 21"/>
-          <p:cNvSpPr txBox="1"/>
-          <p:nvPr/>
-        </p:nvSpPr>
-        <p:spPr>
-          <a:xfrm>
-            <a:off x="9720072" y="3017520"/>
-            <a:ext cx="1828800" cy="685800"/>
+          <p:cNvPr id="27" name="Text 25"/>
+          <p:cNvSpPr txBox="1"/>
+          <p:nvPr/>
+        </p:nvSpPr>
+        <p:spPr>
+          <a:xfrm>
+            <a:off x="9692640" y="2907792"/>
+            <a:ext cx="1883664" cy="658368"/>
           </a:xfrm>
           <a:prstGeom prst="rect">
             <a:avLst/>
@@ -7907,7 +8063,7 @@
               <a:buNone/>
             </a:pPr>
             <a:r>
-              <a:rPr lang="en-US" sz="3200" b="1" dirty="0">
+              <a:rPr lang="en-US" sz="3100" b="1" dirty="0">
                 <a:solidFill>
                   <a:srgbClr val="14201E"/>
                 </a:solidFill>
@@ -7917,20 +8073,20 @@
               </a:rPr>
               <a:t>£25,000</a:t>
             </a:r>
-            <a:endParaRPr lang="en-US" sz="3200" dirty="0"/>
-          </a:p>
-        </p:txBody>
-      </p:sp>
-      <p:sp>
-        <p:nvSpPr>
-          <p:cNvPr id="24" name="Text 22"/>
-          <p:cNvSpPr txBox="1"/>
-          <p:nvPr/>
-        </p:nvSpPr>
-        <p:spPr>
-          <a:xfrm>
-            <a:off x="9765792" y="3794760"/>
-            <a:ext cx="1737360" cy="274320"/>
+            <a:endParaRPr lang="en-US" sz="3100" dirty="0"/>
+          </a:p>
+        </p:txBody>
+      </p:sp>
+      <p:sp>
+        <p:nvSpPr>
+          <p:cNvPr id="28" name="Text 26"/>
+          <p:cNvSpPr txBox="1"/>
+          <p:nvPr/>
+        </p:nvSpPr>
+        <p:spPr>
+          <a:xfrm>
+            <a:off x="9720072" y="3584448"/>
+            <a:ext cx="1828800" cy="256032"/>
           </a:xfrm>
           <a:prstGeom prst="rect">
             <a:avLst/>
@@ -7962,14 +8118,14 @@
       </p:sp>
       <p:sp>
         <p:nvSpPr>
-          <p:cNvPr id="25" name="Text 23"/>
-          <p:cNvSpPr txBox="1"/>
-          <p:nvPr/>
-        </p:nvSpPr>
-        <p:spPr>
-          <a:xfrm>
-            <a:off x="9720072" y="4114800"/>
-            <a:ext cx="1828800" cy="274320"/>
+          <p:cNvPr id="29" name="Text 27"/>
+          <p:cNvSpPr txBox="1"/>
+          <p:nvPr/>
+        </p:nvSpPr>
+        <p:spPr>
+          <a:xfrm>
+            <a:off x="9692640" y="3968496"/>
+            <a:ext cx="1883664" cy="274320"/>
           </a:xfrm>
           <a:prstGeom prst="rect">
             <a:avLst/>
@@ -7985,30 +8141,69 @@
               <a:buNone/>
             </a:pPr>
             <a:r>
-              <a:rPr lang="en-US" sz="1100" b="1" i="1" dirty="0">
+              <a:rPr lang="en-US" sz="1100" b="1" dirty="0">
                 <a:solidFill>
                   <a:srgbClr val="14201E"/>
+                </a:solidFill>
+                <a:latin typeface="Courier New" pitchFamily="34" charset="0"/>
+                <a:ea typeface="Courier New" pitchFamily="34" charset="-122"/>
+                <a:cs typeface="Courier New" pitchFamily="34" charset="-120"/>
+              </a:rPr>
+              <a:t>£100,000 in total</a:t>
+            </a:r>
+            <a:endParaRPr lang="en-US" sz="1100" dirty="0"/>
+          </a:p>
+        </p:txBody>
+      </p:sp>
+      <p:sp>
+        <p:nvSpPr>
+          <p:cNvPr id="30" name="Text 28"/>
+          <p:cNvSpPr txBox="1"/>
+          <p:nvPr/>
+        </p:nvSpPr>
+        <p:spPr>
+          <a:xfrm>
+            <a:off x="548640" y="4846320"/>
+            <a:ext cx="11091672" cy="457200"/>
+          </a:xfrm>
+          <a:prstGeom prst="rect">
+            <a:avLst/>
+          </a:prstGeom>
+          <a:noFill/>
+          <a:ln/>
+        </p:spPr>
+        <p:txBody>
+          <a:bodyPr wrap="square" lIns="0" tIns="0" rIns="0" bIns="0" rtlCol="0" anchor="ctr"/>
+          <a:lstStyle/>
+          <a:p>
+            <a:pPr indent="0" marL="0">
+              <a:buNone/>
+            </a:pPr>
+            <a:r>
+              <a:rPr lang="en-US" sz="1500" dirty="0">
+                <a:solidFill>
+                  <a:srgbClr val="E7EEEC"/>
                 </a:solidFill>
                 <a:latin typeface="Calibri" pitchFamily="34" charset="0"/>
                 <a:ea typeface="Calibri" pitchFamily="34" charset="-122"/>
                 <a:cs typeface="Calibri" pitchFamily="34" charset="-120"/>
               </a:rPr>
-              <a:t>the one to aim at</a:t>
-            </a:r>
-            <a:endParaRPr lang="en-US" sz="1100" dirty="0"/>
-          </a:p>
-        </p:txBody>
-      </p:sp>
-      <p:sp>
-        <p:nvSpPr>
-          <p:cNvPr id="26" name="Text 24"/>
-          <p:cNvSpPr txBox="1"/>
-          <p:nvPr/>
-        </p:nvSpPr>
-        <p:spPr>
-          <a:xfrm>
-            <a:off x="548640" y="4892040"/>
-            <a:ext cx="11091672" cy="457200"/>
+              <a:t>Ten million means £25,000 each — £100,000 shared between the four of you, out of £1,000,000 of fee income above the goal.</a:t>
+            </a:r>
+            <a:endParaRPr lang="en-US" sz="1500" dirty="0"/>
+          </a:p>
+        </p:txBody>
+      </p:sp>
+      <p:sp>
+        <p:nvSpPr>
+          <p:cNvPr id="31" name="Text 29"/>
+          <p:cNvSpPr txBox="1"/>
+          <p:nvPr/>
+        </p:nvSpPr>
+        <p:spPr>
+          <a:xfrm>
+            <a:off x="548640" y="5897880"/>
+            <a:ext cx="11091672" cy="411480"/>
           </a:xfrm>
           <a:prstGeom prst="rect">
             <a:avLst/>
@@ -8024,54 +8219,15 @@
               <a:buNone/>
             </a:pPr>
             <a:r>
-              <a:rPr lang="en-US" sz="1500" dirty="0">
-                <a:solidFill>
-                  <a:srgbClr val="E7EEEC"/>
+              <a:rPr lang="en-US" sz="1100" i="1" dirty="0">
+                <a:solidFill>
+                  <a:srgbClr val="8FA3A0"/>
                 </a:solidFill>
                 <a:latin typeface="Calibri" pitchFamily="34" charset="0"/>
                 <a:ea typeface="Calibri" pitchFamily="34" charset="-122"/>
                 <a:cs typeface="Calibri" pitchFamily="34" charset="-120"/>
               </a:rPr>
-              <a:t>Ten million means twenty five thousand pounds each. That is one million pounds of fee income above the goal — and roughly a June, four times over, plus a little more.</a:t>
-            </a:r>
-            <a:endParaRPr lang="en-US" sz="1500" dirty="0"/>
-          </a:p>
-        </p:txBody>
-      </p:sp>
-      <p:sp>
-        <p:nvSpPr>
-          <p:cNvPr id="27" name="Text 25"/>
-          <p:cNvSpPr txBox="1"/>
-          <p:nvPr/>
-        </p:nvSpPr>
-        <p:spPr>
-          <a:xfrm>
-            <a:off x="548640" y="5943600"/>
-            <a:ext cx="11091672" cy="365760"/>
-          </a:xfrm>
-          <a:prstGeom prst="rect">
-            <a:avLst/>
-          </a:prstGeom>
-          <a:noFill/>
-          <a:ln/>
-        </p:spPr>
-        <p:txBody>
-          <a:bodyPr wrap="square" lIns="0" tIns="0" rIns="0" bIns="0" rtlCol="0" anchor="ctr"/>
-          <a:lstStyle/>
-          <a:p>
-            <a:pPr indent="0" marL="0">
-              <a:buNone/>
-            </a:pPr>
-            <a:r>
-              <a:rPr lang="en-US" sz="1100" i="1" dirty="0">
-                <a:solidFill>
-                  <a:srgbClr val="8FA3A0"/>
-                </a:solidFill>
-                <a:latin typeface="Calibri" pitchFamily="34" charset="0"/>
-                <a:ea typeface="Calibri" pitchFamily="34" charset="-122"/>
-                <a:cs typeface="Calibri" pitchFamily="34" charset="-120"/>
-              </a:rPr>
-              <a:t>Scheme applies per team manager. Confirm eligibility, the payment date, and whether the trigger is invoiced fees or cash collected, before this is announced beyond this room.</a:t>
+              <a:t>The scheme pays 10% of everything above £9m, at every rung. Confirm the payment date and whether the trigger is invoiced fees or cash collected before this is announced.</a:t>
             </a:r>
             <a:endParaRPr lang="en-US" sz="1100" dirty="0"/>
           </a:p>
@@ -8646,7 +8802,7 @@
                 <a:ea typeface="Calibri" pitchFamily="34" charset="-122"/>
                 <a:cs typeface="Calibri" pitchFamily="34" charset="-120"/>
               </a:rPr>
-              <a:t>each, if we get there</a:t>
+              <a:t>each for Emily, Stuart, Cassie and Megan</a:t>
             </a:r>
             <a:endParaRPr lang="en-US" sz="1200" dirty="0"/>
           </a:p>

</xml_diff>

<commit_message>
Set the bonus trigger to invoiced fees and add a build script
The scheme is measured on fees invoiced, not cash collected. Stated on
the bonus slide and said aloud in the presenter script.

Adds reports/build.sh, which re-derives every figure, rebuilds both
decks, regenerates both presenter scripts and runs the slide geometry
check in one command, so the decks and the scripts cannot drift apart.
The presenter-script generator and the geometry checker are now
parameterised rather than hard-coded to one deck.

Co-Authored-By: Claude Opus 5 <noreply@anthropic.com>
Claude-Session: https://claude.ai/code/session_01Bu1rr52xwzmQs6BFkMG9oT
</commit_message>
<xml_diff>
--- a/reports/ytd-road-to-9m.pptx
+++ b/reports/ytd-road-to-9m.pptx
@@ -2597,7 +2597,7 @@
           <a:p>
             <a:r>
               <a:rPr lang="en-US" dirty="0"/>
-              <a:t>Put the three quarters side by side. &lt;break time="0.7s"/&gt; Seventy four per cent, &lt;break time="0.4s"/&gt; then ninety two, &lt;break time="0.4s"/&gt; then sixty four. &lt;break time="0.8s"/&gt; We recovered in quarter two and then gave it back in July and August. &lt;break time="0.7s"/&gt; Those two months together came in at just over half of target. &lt;break time="0.9s"/&gt;</a:t>
+              <a:t>Put the three quarters side by side. &lt;break time="0.7s"/&gt; Seventy four per cent, &lt;break time="0.4s"/&gt; then ninety two, &lt;break time="0.4s"/&gt; then sixty four. &lt;break time="0.8s"/&gt; We recovered in quarter two and then gave it back in July and August. &lt;break time="0.7s"/&gt; Just over half of target between them. &lt;break time="0.9s"/&gt;</a:t>
             </a:r>
             <a:endParaRPr lang="en-US" dirty="0"/>
           </a:p>
@@ -2949,7 +2949,7 @@
           <a:p>
             <a:r>
               <a:rPr lang="en-US" dirty="0"/>
-              <a:t>Now the part worth staying for. &lt;break time="0.8s"/&gt; Nine million is the goal. &lt;break time="0.5s"/&gt; Everything above it is shared between the four of you. &lt;break time="0.6s"/&gt; Emily, &lt;break time="0.25s"/&gt; Stuart, &lt;break time="0.25s"/&gt; Cassie &lt;break time="0.25s"/&gt; and Megan. &lt;break time="0.9s"/&gt; For every two hundred thousand over nine million, &lt;break time="0.5s"/&gt; five thousand pounds each. &lt;break time="0.8s"/&gt; Nine point six million is fifteen thousand. &lt;break time="0.6s"/&gt; And ten million &lt;break time="0.4s"/&gt; is twenty five thousand pounds each. &lt;break time="1s"/&gt;</a:t>
+              <a:t>Now the part worth staying for. &lt;break time="0.8s"/&gt; Nine million is the goal. &lt;break time="0.5s"/&gt; Everything above it is shared between the four of you. &lt;break time="0.6s"/&gt; Emily, &lt;break time="0.25s"/&gt; Stuart, &lt;break time="0.25s"/&gt; Cassie &lt;break time="0.25s"/&gt; and Megan. &lt;break time="0.9s"/&gt; For every two hundred thousand over nine million, &lt;break time="0.5s"/&gt; five thousand pounds each. &lt;break time="0.8s"/&gt; Nine point six million is fifteen thousand. &lt;break time="0.6s"/&gt; And ten million &lt;break time="0.4s"/&gt; is twenty five thousand pounds each. &lt;break time="0.8s"/&gt; Measured on invoiced fees. &lt;break time="0.9s"/&gt;</a:t>
             </a:r>
             <a:endParaRPr lang="en-US" dirty="0"/>
           </a:p>
@@ -8227,7 +8227,7 @@
                 <a:ea typeface="Calibri" pitchFamily="34" charset="-122"/>
                 <a:cs typeface="Calibri" pitchFamily="34" charset="-120"/>
               </a:rPr>
-              <a:t>The scheme pays 10% of everything above £9m, at every rung. Confirm the payment date and whether the trigger is invoiced fees or cash collected before this is announced.</a:t>
+              <a:t>Measured on fees invoiced, not cash collected. The scheme pays 10% of everything above £9m at every rung. Payment date to be confirmed.</a:t>
             </a:r>
             <a:endParaRPr lang="en-US" sz="1100" dirty="0"/>
           </a:p>

</xml_diff>

<commit_message>
Date the September weeks so they cannot be read as Week 1
The September slide labelled its columns Week 1 to Week 4, meaning the
weeks of September. Alongside a separate deck titled Week 1 Fee Board
Review, that collided: the same words meant the first week of September
in one place and last week's board in the other.

The columns are now dated (1-4 Sep, 7-11 Sep, 14-18 Sep, 21-25 Sep) and
the stat cards and script follow. The phrase Week 1 no longer appears
anywhere in the year-to-date deck.

Co-Authored-By: Claude Opus 5 <noreply@anthropic.com>
Claude-Session: https://claude.ai/code/session_01Bu1rr52xwzmQs6BFkMG9oT
</commit_message>
<xml_diff>
--- a/reports/ytd-road-to-9m.pptx
+++ b/reports/ytd-road-to-9m.pptx
@@ -1201,16 +1201,16 @@
                 <c:ptCount val="4"/>
                 <c:lvl>
                   <c:pt idx="0">
-                    <c:v>Week 1</c:v>
+                    <c:v>1–4 Sep</c:v>
                   </c:pt>
                   <c:pt idx="1">
-                    <c:v>Week 2</c:v>
+                    <c:v>7–11 Sep</c:v>
                   </c:pt>
                   <c:pt idx="2">
-                    <c:v>Week 3</c:v>
+                    <c:v>14–18 Sep</c:v>
                   </c:pt>
                   <c:pt idx="3">
-                    <c:v>Week 4</c:v>
+                    <c:v>21–25 Sep</c:v>
                   </c:pt>
                 </c:lvl>
               </c:multiLvlStrCache>
@@ -1291,16 +1291,16 @@
                 <c:ptCount val="4"/>
                 <c:lvl>
                   <c:pt idx="0">
-                    <c:v>Week 1</c:v>
+                    <c:v>1–4 Sep</c:v>
                   </c:pt>
                   <c:pt idx="1">
-                    <c:v>Week 2</c:v>
+                    <c:v>7–11 Sep</c:v>
                   </c:pt>
                   <c:pt idx="2">
-                    <c:v>Week 3</c:v>
+                    <c:v>14–18 Sep</c:v>
                   </c:pt>
                   <c:pt idx="3">
-                    <c:v>Week 4</c:v>
+                    <c:v>21–25 Sep</c:v>
                   </c:pt>
                 </c:lvl>
               </c:multiLvlStrCache>
@@ -2862,7 +2862,7 @@
           <a:p>
             <a:r>
               <a:rPr lang="en-US" dirty="0"/>
-              <a:t>September is the last month of quarter three. &lt;break time="0.7s"/&gt; It needs eight hundred and twenty one thousand. &lt;break time="0.6s"/&gt; Two hundred and forty six thousand is already banked from week one. &lt;break time="0.7s"/&gt; That leaves five hundred and seventy five thousand across the three weeks left. &lt;break time="0.7s"/&gt; One hundred and ninety two thousand a week. &lt;break time="0.6s"/&gt; We beat that pace last week. &lt;break time="0.9s"/&gt;</a:t>
+              <a:t>September is the last month of quarter three. &lt;break time="0.7s"/&gt; It needs eight hundred and twenty one thousand. &lt;break time="0.6s"/&gt; Two hundred and forty six thousand is already banked from the first four days. &lt;break time="0.7s"/&gt; That leaves five hundred and seventy five thousand across the three weeks left. &lt;break time="0.7s"/&gt; One hundred and ninety two thousand a week. &lt;break time="0.6s"/&gt; We beat that pace last week. &lt;break time="0.9s"/&gt;</a:t>
             </a:r>
             <a:endParaRPr lang="en-US" dirty="0"/>
           </a:p>
@@ -7159,7 +7159,7 @@
                 <a:ea typeface="Calibri" pitchFamily="34" charset="-122"/>
                 <a:cs typeface="Calibri" pitchFamily="34" charset="-120"/>
               </a:rPr>
-              <a:t>September needs £820,902. £246,274 is already banked from week one, which leaves £574,628 across the three weeks that remain.</a:t>
+              <a:t>September needs £820,902. £246,274 is already banked from 1–4 September, leaving £574,628 across the three full weeks that remain — with 28–30 September as headroom.</a:t>
             </a:r>
             <a:endParaRPr lang="en-US" sz="1500" dirty="0"/>
           </a:p>
@@ -7342,7 +7342,7 @@
                 <a:ea typeface="Courier New" pitchFamily="34" charset="-122"/>
                 <a:cs typeface="Courier New" pitchFamily="34" charset="-120"/>
               </a:rPr>
-              <a:t>BANKED, WEEK 1</a:t>
+              <a:t>BANKED, 1–4 SEP</a:t>
             </a:r>
             <a:endParaRPr lang="en-US" sz="1050" dirty="0"/>
           </a:p>
@@ -7445,7 +7445,7 @@
                 <a:ea typeface="Courier New" pitchFamily="34" charset="-122"/>
                 <a:cs typeface="Courier New" pitchFamily="34" charset="-120"/>
               </a:rPr>
-              <a:t>PER WEEK, W2–W4</a:t>
+              <a:t>PER WEEK, REMAINING</a:t>
             </a:r>
             <a:endParaRPr lang="en-US" sz="1050" dirty="0"/>
           </a:p>
@@ -9942,7 +9942,7 @@
                 <a:ea typeface="Calibri" pitchFamily="34" charset="-122"/>
                 <a:cs typeface="Calibri" pitchFamily="34" charset="-120"/>
               </a:rPr>
-              <a:t>Beat target in week one. Keep that weekly discipline through Q4</a:t>
+              <a:t>Beat target in the opening week of September. Keep that discipline through Q4</a:t>
             </a:r>
             <a:endParaRPr lang="en-US" sz="1150" dirty="0"/>
           </a:p>

</xml_diff>